<commit_message>
Update name and dates
</commit_message>
<xml_diff>
--- a/Slides/QLS-MiCM_StatisticsInR.pptx
+++ b/Slides/QLS-MiCM_StatisticsInR.pptx
@@ -558,107 +558,6 @@
     </pc:docChg>
   </pc:docChgLst>
   <pc:docChgLst>
-    <pc:chgData name="Adrien Osakwe" userId="7a3e290c-eb83-484b-8e3d-d46ef2333477" providerId="ADAL" clId="{D4A007D3-4E97-4B75-95D0-8B1C64C79F43}"/>
-    <pc:docChg chg="custSel modSld">
-      <pc:chgData name="Adrien Osakwe" userId="7a3e290c-eb83-484b-8e3d-d46ef2333477" providerId="ADAL" clId="{D4A007D3-4E97-4B75-95D0-8B1C64C79F43}" dt="2025-07-13T15:59:41.536" v="56" actId="1076"/>
-      <pc:docMkLst>
-        <pc:docMk/>
-      </pc:docMkLst>
-      <pc:sldChg chg="modSp mod">
-        <pc:chgData name="Adrien Osakwe" userId="7a3e290c-eb83-484b-8e3d-d46ef2333477" providerId="ADAL" clId="{D4A007D3-4E97-4B75-95D0-8B1C64C79F43}" dt="2025-07-13T15:58:49.210" v="50" actId="20577"/>
-        <pc:sldMkLst>
-          <pc:docMk/>
-          <pc:sldMk cId="2389275097" sldId="316"/>
-        </pc:sldMkLst>
-        <pc:spChg chg="mod">
-          <ac:chgData name="Adrien Osakwe" userId="7a3e290c-eb83-484b-8e3d-d46ef2333477" providerId="ADAL" clId="{D4A007D3-4E97-4B75-95D0-8B1C64C79F43}" dt="2025-07-13T15:58:49.210" v="50" actId="20577"/>
-          <ac:spMkLst>
-            <pc:docMk/>
-            <pc:sldMk cId="2389275097" sldId="316"/>
-            <ac:spMk id="2" creationId="{E57E6C04-4051-B883-0FFD-0C104B795BCE}"/>
-          </ac:spMkLst>
-        </pc:spChg>
-      </pc:sldChg>
-      <pc:sldChg chg="addSp delSp modSp mod">
-        <pc:chgData name="Adrien Osakwe" userId="7a3e290c-eb83-484b-8e3d-d46ef2333477" providerId="ADAL" clId="{D4A007D3-4E97-4B75-95D0-8B1C64C79F43}" dt="2025-07-13T15:57:41.585" v="15" actId="1076"/>
-        <pc:sldMkLst>
-          <pc:docMk/>
-          <pc:sldMk cId="25426801" sldId="318"/>
-        </pc:sldMkLst>
-        <pc:spChg chg="add del">
-          <ac:chgData name="Adrien Osakwe" userId="7a3e290c-eb83-484b-8e3d-d46ef2333477" providerId="ADAL" clId="{D4A007D3-4E97-4B75-95D0-8B1C64C79F43}" dt="2025-07-13T15:56:28.308" v="2" actId="478"/>
-          <ac:spMkLst>
-            <pc:docMk/>
-            <pc:sldMk cId="25426801" sldId="318"/>
-            <ac:spMk id="3" creationId="{7710DF1F-7E9B-BAEB-0219-3FE3E99E5556}"/>
-          </ac:spMkLst>
-        </pc:spChg>
-        <pc:spChg chg="add del mod">
-          <ac:chgData name="Adrien Osakwe" userId="7a3e290c-eb83-484b-8e3d-d46ef2333477" providerId="ADAL" clId="{D4A007D3-4E97-4B75-95D0-8B1C64C79F43}" dt="2025-07-13T15:57:22.204" v="4" actId="478"/>
-          <ac:spMkLst>
-            <pc:docMk/>
-            <pc:sldMk cId="25426801" sldId="318"/>
-            <ac:spMk id="5" creationId="{04653E2A-F453-98D7-FC1C-D61B4A04B9EE}"/>
-          </ac:spMkLst>
-        </pc:spChg>
-        <pc:picChg chg="del">
-          <ac:chgData name="Adrien Osakwe" userId="7a3e290c-eb83-484b-8e3d-d46ef2333477" providerId="ADAL" clId="{D4A007D3-4E97-4B75-95D0-8B1C64C79F43}" dt="2025-07-13T15:56:24.301" v="0" actId="478"/>
-          <ac:picMkLst>
-            <pc:docMk/>
-            <pc:sldMk cId="25426801" sldId="318"/>
-            <ac:picMk id="8" creationId="{A26D50DA-518D-0AF2-D362-2940796A3E8A}"/>
-          </ac:picMkLst>
-        </pc:picChg>
-        <pc:picChg chg="add mod">
-          <ac:chgData name="Adrien Osakwe" userId="7a3e290c-eb83-484b-8e3d-d46ef2333477" providerId="ADAL" clId="{D4A007D3-4E97-4B75-95D0-8B1C64C79F43}" dt="2025-07-13T15:57:41.585" v="15" actId="1076"/>
-          <ac:picMkLst>
-            <pc:docMk/>
-            <pc:sldMk cId="25426801" sldId="318"/>
-            <ac:picMk id="13" creationId="{6DF5BB46-1153-E294-A4F1-5DF7C89C4F2C}"/>
-          </ac:picMkLst>
-        </pc:picChg>
-      </pc:sldChg>
-      <pc:sldChg chg="addSp delSp modSp mod">
-        <pc:chgData name="Adrien Osakwe" userId="7a3e290c-eb83-484b-8e3d-d46ef2333477" providerId="ADAL" clId="{D4A007D3-4E97-4B75-95D0-8B1C64C79F43}" dt="2025-07-13T15:59:41.536" v="56" actId="1076"/>
-        <pc:sldMkLst>
-          <pc:docMk/>
-          <pc:sldMk cId="3301951615" sldId="338"/>
-        </pc:sldMkLst>
-        <pc:picChg chg="add mod">
-          <ac:chgData name="Adrien Osakwe" userId="7a3e290c-eb83-484b-8e3d-d46ef2333477" providerId="ADAL" clId="{D4A007D3-4E97-4B75-95D0-8B1C64C79F43}" dt="2025-07-13T15:59:41.536" v="56" actId="1076"/>
-          <ac:picMkLst>
-            <pc:docMk/>
-            <pc:sldMk cId="3301951615" sldId="338"/>
-            <ac:picMk id="3" creationId="{144E657E-4DB2-77E6-0E22-D9223E12F50D}"/>
-          </ac:picMkLst>
-        </pc:picChg>
-        <pc:picChg chg="del">
-          <ac:chgData name="Adrien Osakwe" userId="7a3e290c-eb83-484b-8e3d-d46ef2333477" providerId="ADAL" clId="{D4A007D3-4E97-4B75-95D0-8B1C64C79F43}" dt="2025-07-13T15:59:07.324" v="51" actId="478"/>
-          <ac:picMkLst>
-            <pc:docMk/>
-            <pc:sldMk cId="3301951615" sldId="338"/>
-            <ac:picMk id="5" creationId="{19B22BFB-B19D-2D0C-A86A-B8456CFB8D45}"/>
-          </ac:picMkLst>
-        </pc:picChg>
-      </pc:sldChg>
-      <pc:sldChg chg="modSp mod">
-        <pc:chgData name="Adrien Osakwe" userId="7a3e290c-eb83-484b-8e3d-d46ef2333477" providerId="ADAL" clId="{D4A007D3-4E97-4B75-95D0-8B1C64C79F43}" dt="2025-07-13T15:58:18.607" v="18" actId="20577"/>
-        <pc:sldMkLst>
-          <pc:docMk/>
-          <pc:sldMk cId="3856371583" sldId="482"/>
-        </pc:sldMkLst>
-        <pc:spChg chg="mod">
-          <ac:chgData name="Adrien Osakwe" userId="7a3e290c-eb83-484b-8e3d-d46ef2333477" providerId="ADAL" clId="{D4A007D3-4E97-4B75-95D0-8B1C64C79F43}" dt="2025-07-13T15:58:18.607" v="18" actId="20577"/>
-          <ac:spMkLst>
-            <pc:docMk/>
-            <pc:sldMk cId="3856371583" sldId="482"/>
-            <ac:spMk id="2" creationId="{845BB119-6782-CBD8-8DCB-F8C750D639F4}"/>
-          </ac:spMkLst>
-        </pc:spChg>
-      </pc:sldChg>
-    </pc:docChg>
-  </pc:docChgLst>
-  <pc:docChgLst>
     <pc:chgData name="Adrien Osakwe" userId="7a3e290c-eb83-484b-8e3d-d46ef2333477" providerId="ADAL" clId="{ECB69157-50F4-4BCE-8F3E-6963454F02B1}"/>
     <pc:docChg chg="custSel addSld delSld modSld sldOrd">
       <pc:chgData name="Adrien Osakwe" userId="7a3e290c-eb83-484b-8e3d-d46ef2333477" providerId="ADAL" clId="{ECB69157-50F4-4BCE-8F3E-6963454F02B1}" dt="2025-02-20T17:16:50.767" v="423"/>
@@ -821,6 +720,107 @@
       </pc:sldChg>
     </pc:docChg>
   </pc:docChgLst>
+  <pc:docChgLst>
+    <pc:chgData name="Adrien Osakwe" userId="7a3e290c-eb83-484b-8e3d-d46ef2333477" providerId="ADAL" clId="{D4A007D3-4E97-4B75-95D0-8B1C64C79F43}"/>
+    <pc:docChg chg="custSel modSld">
+      <pc:chgData name="Adrien Osakwe" userId="7a3e290c-eb83-484b-8e3d-d46ef2333477" providerId="ADAL" clId="{D4A007D3-4E97-4B75-95D0-8B1C64C79F43}" dt="2025-07-13T15:59:41.536" v="56" actId="1076"/>
+      <pc:docMkLst>
+        <pc:docMk/>
+      </pc:docMkLst>
+      <pc:sldChg chg="modSp mod">
+        <pc:chgData name="Adrien Osakwe" userId="7a3e290c-eb83-484b-8e3d-d46ef2333477" providerId="ADAL" clId="{D4A007D3-4E97-4B75-95D0-8B1C64C79F43}" dt="2025-07-13T15:58:49.210" v="50" actId="20577"/>
+        <pc:sldMkLst>
+          <pc:docMk/>
+          <pc:sldMk cId="2389275097" sldId="316"/>
+        </pc:sldMkLst>
+        <pc:spChg chg="mod">
+          <ac:chgData name="Adrien Osakwe" userId="7a3e290c-eb83-484b-8e3d-d46ef2333477" providerId="ADAL" clId="{D4A007D3-4E97-4B75-95D0-8B1C64C79F43}" dt="2025-07-13T15:58:49.210" v="50" actId="20577"/>
+          <ac:spMkLst>
+            <pc:docMk/>
+            <pc:sldMk cId="2389275097" sldId="316"/>
+            <ac:spMk id="2" creationId="{E57E6C04-4051-B883-0FFD-0C104B795BCE}"/>
+          </ac:spMkLst>
+        </pc:spChg>
+      </pc:sldChg>
+      <pc:sldChg chg="addSp delSp modSp mod">
+        <pc:chgData name="Adrien Osakwe" userId="7a3e290c-eb83-484b-8e3d-d46ef2333477" providerId="ADAL" clId="{D4A007D3-4E97-4B75-95D0-8B1C64C79F43}" dt="2025-07-13T15:57:41.585" v="15" actId="1076"/>
+        <pc:sldMkLst>
+          <pc:docMk/>
+          <pc:sldMk cId="25426801" sldId="318"/>
+        </pc:sldMkLst>
+        <pc:spChg chg="add del">
+          <ac:chgData name="Adrien Osakwe" userId="7a3e290c-eb83-484b-8e3d-d46ef2333477" providerId="ADAL" clId="{D4A007D3-4E97-4B75-95D0-8B1C64C79F43}" dt="2025-07-13T15:56:28.308" v="2" actId="478"/>
+          <ac:spMkLst>
+            <pc:docMk/>
+            <pc:sldMk cId="25426801" sldId="318"/>
+            <ac:spMk id="3" creationId="{7710DF1F-7E9B-BAEB-0219-3FE3E99E5556}"/>
+          </ac:spMkLst>
+        </pc:spChg>
+        <pc:spChg chg="add del mod">
+          <ac:chgData name="Adrien Osakwe" userId="7a3e290c-eb83-484b-8e3d-d46ef2333477" providerId="ADAL" clId="{D4A007D3-4E97-4B75-95D0-8B1C64C79F43}" dt="2025-07-13T15:57:22.204" v="4" actId="478"/>
+          <ac:spMkLst>
+            <pc:docMk/>
+            <pc:sldMk cId="25426801" sldId="318"/>
+            <ac:spMk id="5" creationId="{04653E2A-F453-98D7-FC1C-D61B4A04B9EE}"/>
+          </ac:spMkLst>
+        </pc:spChg>
+        <pc:picChg chg="del">
+          <ac:chgData name="Adrien Osakwe" userId="7a3e290c-eb83-484b-8e3d-d46ef2333477" providerId="ADAL" clId="{D4A007D3-4E97-4B75-95D0-8B1C64C79F43}" dt="2025-07-13T15:56:24.301" v="0" actId="478"/>
+          <ac:picMkLst>
+            <pc:docMk/>
+            <pc:sldMk cId="25426801" sldId="318"/>
+            <ac:picMk id="8" creationId="{A26D50DA-518D-0AF2-D362-2940796A3E8A}"/>
+          </ac:picMkLst>
+        </pc:picChg>
+        <pc:picChg chg="add mod">
+          <ac:chgData name="Adrien Osakwe" userId="7a3e290c-eb83-484b-8e3d-d46ef2333477" providerId="ADAL" clId="{D4A007D3-4E97-4B75-95D0-8B1C64C79F43}" dt="2025-07-13T15:57:41.585" v="15" actId="1076"/>
+          <ac:picMkLst>
+            <pc:docMk/>
+            <pc:sldMk cId="25426801" sldId="318"/>
+            <ac:picMk id="13" creationId="{6DF5BB46-1153-E294-A4F1-5DF7C89C4F2C}"/>
+          </ac:picMkLst>
+        </pc:picChg>
+      </pc:sldChg>
+      <pc:sldChg chg="addSp delSp modSp mod">
+        <pc:chgData name="Adrien Osakwe" userId="7a3e290c-eb83-484b-8e3d-d46ef2333477" providerId="ADAL" clId="{D4A007D3-4E97-4B75-95D0-8B1C64C79F43}" dt="2025-07-13T15:59:41.536" v="56" actId="1076"/>
+        <pc:sldMkLst>
+          <pc:docMk/>
+          <pc:sldMk cId="3301951615" sldId="338"/>
+        </pc:sldMkLst>
+        <pc:picChg chg="add mod">
+          <ac:chgData name="Adrien Osakwe" userId="7a3e290c-eb83-484b-8e3d-d46ef2333477" providerId="ADAL" clId="{D4A007D3-4E97-4B75-95D0-8B1C64C79F43}" dt="2025-07-13T15:59:41.536" v="56" actId="1076"/>
+          <ac:picMkLst>
+            <pc:docMk/>
+            <pc:sldMk cId="3301951615" sldId="338"/>
+            <ac:picMk id="3" creationId="{144E657E-4DB2-77E6-0E22-D9223E12F50D}"/>
+          </ac:picMkLst>
+        </pc:picChg>
+        <pc:picChg chg="del">
+          <ac:chgData name="Adrien Osakwe" userId="7a3e290c-eb83-484b-8e3d-d46ef2333477" providerId="ADAL" clId="{D4A007D3-4E97-4B75-95D0-8B1C64C79F43}" dt="2025-07-13T15:59:07.324" v="51" actId="478"/>
+          <ac:picMkLst>
+            <pc:docMk/>
+            <pc:sldMk cId="3301951615" sldId="338"/>
+            <ac:picMk id="5" creationId="{19B22BFB-B19D-2D0C-A86A-B8456CFB8D45}"/>
+          </ac:picMkLst>
+        </pc:picChg>
+      </pc:sldChg>
+      <pc:sldChg chg="modSp mod">
+        <pc:chgData name="Adrien Osakwe" userId="7a3e290c-eb83-484b-8e3d-d46ef2333477" providerId="ADAL" clId="{D4A007D3-4E97-4B75-95D0-8B1C64C79F43}" dt="2025-07-13T15:58:18.607" v="18" actId="20577"/>
+        <pc:sldMkLst>
+          <pc:docMk/>
+          <pc:sldMk cId="3856371583" sldId="482"/>
+        </pc:sldMkLst>
+        <pc:spChg chg="mod">
+          <ac:chgData name="Adrien Osakwe" userId="7a3e290c-eb83-484b-8e3d-d46ef2333477" providerId="ADAL" clId="{D4A007D3-4E97-4B75-95D0-8B1C64C79F43}" dt="2025-07-13T15:58:18.607" v="18" actId="20577"/>
+          <ac:spMkLst>
+            <pc:docMk/>
+            <pc:sldMk cId="3856371583" sldId="482"/>
+            <ac:spMk id="2" creationId="{845BB119-6782-CBD8-8DCB-F8C750D639F4}"/>
+          </ac:spMkLst>
+        </pc:spChg>
+      </pc:sldChg>
+    </pc:docChg>
+  </pc:docChgLst>
 </pc:chgInfo>
 </file>
 
@@ -918,7 +918,7 @@
           <a:p>
             <a:fld id="{9FF74AA5-8A3E-4FDB-94BB-BF4B31CB4E38}" type="datetimeFigureOut">
               <a:rPr lang="en-CA" smtClean="0"/>
-              <a:t>2026-06-16</a:t>
+              <a:t>2026-10-16</a:t>
             </a:fld>
             <a:endParaRPr lang="en-CA"/>
           </a:p>
@@ -1095,7 +1095,7 @@
           <a:p>
             <a:fld id="{217E5156-1B5D-054E-B5B2-E1B1BA160252}" type="datetimeFigureOut">
               <a:rPr lang="fr-FR" smtClean="0"/>
-              <a:t>16/06/2026</a:t>
+              <a:t>16/10/2026</a:t>
             </a:fld>
             <a:endParaRPr lang="fr-FR"/>
           </a:p>
@@ -5895,10 +5895,7 @@
                 <a:pPr/>
                 <a14:m>
                   <m:oMathPara xmlns:m="http://schemas.openxmlformats.org/officeDocument/2006/math">
-                    <m:oMathParaPr>
-                      <m:jc m:val="centerGroup"/>
-                    </m:oMathParaPr>
-                    <m:oMath xmlns:m="http://schemas.openxmlformats.org/officeDocument/2006/math">
+                    <m:oMath>
                       <m:acc>
                         <m:accPr>
                           <m:chr m:val="̂"/>
@@ -5927,7 +5924,7 @@
                         <m:accPr>
                           <m:chr m:val="̂"/>
                           <m:ctrlPr>
-                            <a:rPr lang="en-CA" sz="3600" i="1">
+                            <a:rPr lang="en-CA" sz="3600" b="0" i="1" smtClean="0">
                               <a:latin typeface="Cambria Math" panose="02040503050406030204" pitchFamily="18" charset="0"/>
                             </a:rPr>
                           </m:ctrlPr>
@@ -6033,10 +6030,7 @@
                 <a:pPr/>
                 <a14:m>
                   <m:oMathPara xmlns:m="http://schemas.openxmlformats.org/officeDocument/2006/math">
-                    <m:oMathParaPr>
-                      <m:jc m:val="centerGroup"/>
-                    </m:oMathParaPr>
-                    <m:oMath xmlns:m="http://schemas.openxmlformats.org/officeDocument/2006/math">
+                    <m:oMath>
                       <m:r>
                         <a:rPr lang="en-CA" sz="3600" b="0" i="1" smtClean="0">
                           <a:latin typeface="Cambria Math" panose="02040503050406030204" pitchFamily="18" charset="0"/>
@@ -6159,10 +6153,7 @@
                 <a:pPr/>
                 <a14:m>
                   <m:oMathPara xmlns:m="http://schemas.openxmlformats.org/officeDocument/2006/math">
-                    <m:oMathParaPr>
-                      <m:jc m:val="centerGroup"/>
-                    </m:oMathParaPr>
-                    <m:oMath xmlns:m="http://schemas.openxmlformats.org/officeDocument/2006/math">
+                    <m:oMath>
                       <m:r>
                         <a:rPr lang="en-CA" sz="3200" b="0" i="1" smtClean="0">
                           <a:latin typeface="Cambria Math" panose="02040503050406030204" pitchFamily="18" charset="0"/>
@@ -6178,7 +6169,7 @@
                       <m:f>
                         <m:fPr>
                           <m:ctrlPr>
-                            <a:rPr lang="en-CA" sz="3200" b="0" i="1" smtClean="0">
+                            <a:rPr lang="en-CA" sz="3200" i="1">
                               <a:latin typeface="Cambria Math" panose="02040503050406030204" pitchFamily="18" charset="0"/>
                             </a:rPr>
                           </m:ctrlPr>
@@ -7326,36 +7317,15 @@
               <a:rPr lang="en-CA" sz="2400" dirty="0">
                 <a:latin typeface="Helvetica Light"/>
               </a:rPr>
-              <a:t>Workshop Lead: </a:t>
-            </a:r>
-            <a:r>
-              <a:rPr lang="en-CA" sz="2400" dirty="0" err="1">
-                <a:latin typeface="Helvetica Light"/>
-              </a:rPr>
-              <a:t>Xiaoqi</a:t>
-            </a:r>
+              <a:t>Workshop Lead: Sameena Karsan</a:t>
+            </a:r>
+          </a:p>
+          <a:p>
             <a:r>
               <a:rPr lang="en-CA" sz="2400" dirty="0">
                 <a:latin typeface="Helvetica Light"/>
               </a:rPr>
-              <a:t> </a:t>
-            </a:r>
-            <a:r>
-              <a:rPr lang="en-CA" sz="2400" dirty="0" err="1">
-                <a:latin typeface="Helvetica Light"/>
-              </a:rPr>
-              <a:t>Xie</a:t>
-            </a:r>
-            <a:endParaRPr lang="en-CA" sz="2400" dirty="0">
-              <a:latin typeface="Helvetica Light"/>
-            </a:endParaRPr>
-          </a:p>
-          <a:p>
-            <a:r>
-              <a:rPr lang="en-CA" sz="2400" dirty="0">
-                <a:latin typeface="Helvetica Light"/>
-              </a:rPr>
-              <a:t>June 19, 2026</a:t>
+              <a:t>October 19, 2026</a:t>
             </a:r>
           </a:p>
         </p:txBody>
@@ -8755,7 +8725,7 @@
                     <m:sSub>
                       <m:sSubPr>
                         <m:ctrlPr>
-                          <a:rPr lang="en-CA" sz="2000" b="0" i="1" smtClean="0">
+                          <a:rPr lang="en-CA" sz="2000" i="1">
                             <a:latin typeface="Cambria Math" panose="02040503050406030204" pitchFamily="18" charset="0"/>
                           </a:rPr>
                         </m:ctrlPr>
@@ -8895,10 +8865,7 @@
                 <a:pPr/>
                 <a14:m>
                   <m:oMathPara xmlns:m="http://schemas.openxmlformats.org/officeDocument/2006/math">
-                    <m:oMathParaPr>
-                      <m:jc m:val="centerGroup"/>
-                    </m:oMathParaPr>
-                    <m:oMath xmlns:m="http://schemas.openxmlformats.org/officeDocument/2006/math">
+                    <m:oMath>
                       <m:r>
                         <a:rPr lang="en-CA" sz="2400" b="0" i="1" smtClean="0">
                           <a:latin typeface="Cambria Math" panose="02040503050406030204" pitchFamily="18" charset="0"/>
@@ -9444,10 +9411,7 @@
                 <a:pPr/>
                 <a14:m>
                   <m:oMathPara xmlns:m="http://schemas.openxmlformats.org/officeDocument/2006/math">
-                    <m:oMathParaPr>
-                      <m:jc m:val="centerGroup"/>
-                    </m:oMathParaPr>
-                    <m:oMath xmlns:m="http://schemas.openxmlformats.org/officeDocument/2006/math">
+                    <m:oMath>
                       <m:r>
                         <a:rPr lang="en-CA" b="0" i="1" smtClean="0">
                           <a:latin typeface="Cambria Math" panose="02040503050406030204" pitchFamily="18" charset="0"/>
@@ -9591,10 +9555,7 @@
                 <a:pPr/>
                 <a14:m>
                   <m:oMathPara xmlns:m="http://schemas.openxmlformats.org/officeDocument/2006/math">
-                    <m:oMathParaPr>
-                      <m:jc m:val="centerGroup"/>
-                    </m:oMathParaPr>
-                    <m:oMath xmlns:m="http://schemas.openxmlformats.org/officeDocument/2006/math">
+                    <m:oMath>
                       <m:r>
                         <a:rPr lang="en-CA" b="0" i="1" smtClean="0">
                           <a:latin typeface="Cambria Math" panose="02040503050406030204" pitchFamily="18" charset="0"/>
@@ -10591,10 +10552,7 @@
                 <a:pPr/>
                 <a14:m>
                   <m:oMathPara xmlns:m="http://schemas.openxmlformats.org/officeDocument/2006/math">
-                    <m:oMathParaPr>
-                      <m:jc m:val="centerGroup"/>
-                    </m:oMathParaPr>
-                    <m:oMath xmlns:m="http://schemas.openxmlformats.org/officeDocument/2006/math">
+                    <m:oMath>
                       <m:r>
                         <a:rPr lang="en-CA" b="0" i="1" smtClean="0">
                           <a:latin typeface="Cambria Math" panose="02040503050406030204" pitchFamily="18" charset="0"/>
@@ -11511,10 +11469,7 @@
                 <a:pPr/>
                 <a14:m>
                   <m:oMathPara xmlns:m="http://schemas.openxmlformats.org/officeDocument/2006/math">
-                    <m:oMathParaPr>
-                      <m:jc m:val="centerGroup"/>
-                    </m:oMathParaPr>
-                    <m:oMath xmlns:m="http://schemas.openxmlformats.org/officeDocument/2006/math">
+                    <m:oMath>
                       <m:r>
                         <a:rPr lang="en-CA" b="0" i="1" smtClean="0">
                           <a:latin typeface="Cambria Math" panose="02040503050406030204" pitchFamily="18" charset="0"/>
@@ -11583,10 +11538,7 @@
                 <a:pPr/>
                 <a14:m>
                   <m:oMathPara xmlns:m="http://schemas.openxmlformats.org/officeDocument/2006/math">
-                    <m:oMathParaPr>
-                      <m:jc m:val="centerGroup"/>
-                    </m:oMathParaPr>
-                    <m:oMath xmlns:m="http://schemas.openxmlformats.org/officeDocument/2006/math">
+                    <m:oMath>
                       <m:r>
                         <a:rPr lang="en-CA" b="0" i="1" smtClean="0">
                           <a:latin typeface="Cambria Math" panose="02040503050406030204" pitchFamily="18" charset="0"/>
@@ -11847,10 +11799,7 @@
                 <a:pPr/>
                 <a14:m>
                   <m:oMathPara xmlns:m="http://schemas.openxmlformats.org/officeDocument/2006/math">
-                    <m:oMathParaPr>
-                      <m:jc m:val="centerGroup"/>
-                    </m:oMathParaPr>
-                    <m:oMath xmlns:m="http://schemas.openxmlformats.org/officeDocument/2006/math">
+                    <m:oMath>
                       <m:sSub>
                         <m:sSubPr>
                           <m:ctrlPr>
@@ -12036,10 +11985,7 @@
                 <a:pPr/>
                 <a14:m>
                   <m:oMathPara xmlns:m="http://schemas.openxmlformats.org/officeDocument/2006/math">
-                    <m:oMathParaPr>
-                      <m:jc m:val="centerGroup"/>
-                    </m:oMathParaPr>
-                    <m:oMath xmlns:m="http://schemas.openxmlformats.org/officeDocument/2006/math">
+                    <m:oMath>
                       <m:r>
                         <m:rPr>
                           <m:nor/>
@@ -12047,52 +11993,7 @@
                         <a:rPr lang="en-US" i="1" dirty="0">
                           <a:latin typeface="Cambria Math" panose="02040503050406030204" pitchFamily="18" charset="0"/>
                         </a:rPr>
-                        <m:t>Effect</m:t>
-                      </m:r>
-                      <m:r>
-                        <m:rPr>
-                          <m:nor/>
-                        </m:rPr>
-                        <a:rPr lang="en-US" i="1" dirty="0">
-                          <a:latin typeface="Cambria Math" panose="02040503050406030204" pitchFamily="18" charset="0"/>
-                        </a:rPr>
-                        <m:t> </m:t>
-                      </m:r>
-                      <m:r>
-                        <m:rPr>
-                          <m:nor/>
-                        </m:rPr>
-                        <a:rPr lang="en-US" i="1" dirty="0">
-                          <a:latin typeface="Cambria Math" panose="02040503050406030204" pitchFamily="18" charset="0"/>
-                        </a:rPr>
-                        <m:t>Size</m:t>
-                      </m:r>
-                      <m:r>
-                        <m:rPr>
-                          <m:nor/>
-                        </m:rPr>
-                        <a:rPr lang="en-US" i="1" dirty="0">
-                          <a:latin typeface="Cambria Math" panose="02040503050406030204" pitchFamily="18" charset="0"/>
-                        </a:rPr>
-                        <m:t> (</m:t>
-                      </m:r>
-                      <m:r>
-                        <m:rPr>
-                          <m:nor/>
-                        </m:rPr>
-                        <a:rPr lang="en-US" i="1" dirty="0">
-                          <a:latin typeface="Cambria Math" panose="02040503050406030204" pitchFamily="18" charset="0"/>
-                        </a:rPr>
-                        <m:t>ES</m:t>
-                      </m:r>
-                      <m:r>
-                        <m:rPr>
-                          <m:nor/>
-                        </m:rPr>
-                        <a:rPr lang="en-US" i="1" dirty="0">
-                          <a:latin typeface="Cambria Math" panose="02040503050406030204" pitchFamily="18" charset="0"/>
-                        </a:rPr>
-                        <m:t>)</m:t>
+                        <m:t>Effect Size (ES)</m:t>
                       </m:r>
                       <m:r>
                         <a:rPr lang="en-CA" i="1">
@@ -12863,10 +12764,10 @@
       </p:sp>
       <p:pic>
         <p:nvPicPr>
-          <p:cNvPr id="5" name="Picture 4">
+          <p:cNvPr id="2" name="Picture 1">
             <a:extLst>
               <a:ext uri="{FF2B5EF4-FFF2-40B4-BE49-F238E27FC236}">
-                <a16:creationId xmlns:a16="http://schemas.microsoft.com/office/drawing/2014/main" id="{9B93134F-FF7B-911C-9C83-FF364901C19A}"/>
+                <a16:creationId xmlns:a16="http://schemas.microsoft.com/office/drawing/2014/main" id="{0FE76530-461F-E6D8-06B6-3E284F756476}"/>
               </a:ext>
             </a:extLst>
           </p:cNvPr>
@@ -12883,8 +12784,8 @@
         </p:blipFill>
         <p:spPr>
           <a:xfrm>
-            <a:off x="1723073" y="2021977"/>
-            <a:ext cx="5401627" cy="3312648"/>
+            <a:off x="1647890" y="2122319"/>
+            <a:ext cx="5766521" cy="3019836"/>
           </a:xfrm>
           <a:prstGeom prst="rect">
             <a:avLst/>

</xml_diff>